<commit_message>
docs(presentations): update PPTX decks, generators, and HTML presentations for on-demand PDF conversion & Graviton compute
</commit_message>
<xml_diff>
--- a/AWS_Document_Management_Platform_Architecture.pptx
+++ b/AWS_Document_Management_Platform_Architecture.pptx
@@ -27,6 +27,7 @@
     <p:sldId id="275" r:id="rId26"/>
     <p:sldId id="276" r:id="rId27"/>
     <p:sldId id="277" r:id="rId28"/>
+    <p:sldId id="278" r:id="rId29"/>
   </p:sldIdLst>
   <p:sldSz cx="12191695" cy="6858000" type="screen4x3"/>
   <p:notesSz cx="6858000" cy="9144000"/>
@@ -3846,7 +3847,7 @@
               </a:defRPr>
             </a:pPr>
             <a:r>
-              <a:t>1 / 22</a:t>
+              <a:t>1 / 23</a:t>
             </a:r>
           </a:p>
         </p:txBody>
@@ -6076,7 +6077,7 @@
               </a:defRPr>
             </a:pPr>
             <a:r>
-              <a:t>10 / 22</a:t>
+              <a:t>10 / 23</a:t>
             </a:r>
           </a:p>
         </p:txBody>
@@ -6566,7 +6567,7 @@
               </a:defRPr>
             </a:pPr>
             <a:r>
-              <a:t>11 / 22</a:t>
+              <a:t>11 / 23</a:t>
             </a:r>
           </a:p>
         </p:txBody>
@@ -6920,7 +6921,7 @@
               </a:defRPr>
             </a:pPr>
             <a:r>
-              <a:t>12 / 22</a:t>
+              <a:t>12 / 23</a:t>
             </a:r>
           </a:p>
         </p:txBody>
@@ -7270,7 +7271,7 @@
               </a:defRPr>
             </a:pPr>
             <a:r>
-              <a:t>13 / 22</a:t>
+              <a:t>13 / 23</a:t>
             </a:r>
           </a:p>
         </p:txBody>
@@ -7620,7 +7621,7 @@
               </a:defRPr>
             </a:pPr>
             <a:r>
-              <a:t>14 / 22</a:t>
+              <a:t>14 / 23</a:t>
             </a:r>
           </a:p>
         </p:txBody>
@@ -7970,7 +7971,7 @@
               </a:defRPr>
             </a:pPr>
             <a:r>
-              <a:t>15 / 22</a:t>
+              <a:t>15 / 23</a:t>
             </a:r>
           </a:p>
         </p:txBody>
@@ -8460,7 +8461,7 @@
               </a:defRPr>
             </a:pPr>
             <a:r>
-              <a:t>16 / 22</a:t>
+              <a:t>16 / 23</a:t>
             </a:r>
           </a:p>
         </p:txBody>
@@ -8810,7 +8811,7 @@
               </a:defRPr>
             </a:pPr>
             <a:r>
-              <a:t>17 / 22</a:t>
+              <a:t>17 / 23</a:t>
             </a:r>
           </a:p>
         </p:txBody>
@@ -8872,7 +8873,7 @@
               </a:defRPr>
             </a:pPr>
             <a:r>
-              <a:t>API EXECUTION SEQUENCE</a:t>
+              <a:t>DERIVED READ MODEL &amp; TRANSFORMATION</a:t>
             </a:r>
           </a:p>
         </p:txBody>
@@ -8908,7 +8909,7 @@
               </a:defRPr>
             </a:pPr>
             <a:r>
-              <a:t>Sequence Deep Dive: OpenSearch Search &amp; Deep Health Probe</a:t>
+              <a:t>On-Demand Format Conversion &amp; Derivative Caching (JPEG/PNG to PDF)</a:t>
             </a:r>
           </a:p>
         </p:txBody>
@@ -8944,7 +8945,7 @@
               </a:defRPr>
             </a:pPr>
             <a:r>
-              <a:t>API Sequences 15 &amp; 01: POST /v1/search &amp; GET /health</a:t>
+              <a:t>Dynamic In-Memory Transformation, S3 Derivative Caching &amp; WORM Lineage Invariance</a:t>
             </a:r>
           </a:p>
         </p:txBody>
@@ -8957,8 +8958,8 @@
         </p:nvSpPr>
         <p:spPr>
           <a:xfrm>
-            <a:off x="731520" y="5120640"/>
-            <a:ext cx="10728655" cy="1097280"/>
+            <a:off x="731520" y="1508760"/>
+            <a:ext cx="3332073" cy="3429000"/>
           </a:xfrm>
           <a:prstGeom prst="roundRect">
             <a:avLst/>
@@ -9002,8 +9003,8 @@
         </p:nvSpPr>
         <p:spPr>
           <a:xfrm>
-            <a:off x="914400" y="5193792"/>
-            <a:ext cx="10362895" cy="914400"/>
+            <a:off x="914400" y="1691640"/>
+            <a:ext cx="2966313" cy="3063240"/>
           </a:xfrm>
           <a:prstGeom prst="rect">
             <a:avLst/>
@@ -9017,22 +9018,506 @@
           <a:lstStyle/>
           <a:p>
             <a:pPr>
+              <a:defRPr sz="1200" b="1">
+                <a:solidFill>
+                  <a:srgbClr val="38BDF8"/>
+                </a:solidFill>
+                <a:latin typeface="Segoe UI"/>
+              </a:defRPr>
+            </a:pPr>
+            <a:r>
+              <a:t>⚡ In-Memory Transformation</a:t>
+            </a:r>
+          </a:p>
+          <a:p>
+            <a:pPr>
+              <a:spcBef>
+                <a:spcPts val="600"/>
+              </a:spcBef>
+              <a:defRPr sz="950" b="1">
+                <a:solidFill>
+                  <a:srgbClr val="FF9900"/>
+                </a:solidFill>
+                <a:latin typeface="Segoe UI"/>
+              </a:defRPr>
+            </a:pPr>
+            <a:r>
+              <a:t>Pure TypeScript Engine: </a:t>
+            </a:r>
+            <a:r>
+              <a:rPr sz="900">
+                <a:solidFill>
+                  <a:srgbClr val="94A3B8"/>
+                </a:solidFill>
+                <a:latin typeface="Segoe UI"/>
+              </a:rPr>
+              <a:t>Uses lightweight pdf-lib for in-memory byte streaming without external binaries (ImageMagick/Ghostscript).</a:t>
+            </a:r>
+          </a:p>
+          <a:p>
+            <a:pPr>
+              <a:spcBef>
+                <a:spcPts val="600"/>
+              </a:spcBef>
+              <a:defRPr sz="950" b="1">
+                <a:solidFill>
+                  <a:srgbClr val="FF9900"/>
+                </a:solidFill>
+                <a:latin typeface="Segoe UI"/>
+              </a:defRPr>
+            </a:pPr>
+            <a:r>
+              <a:t>AWS Graviton (ARM64): </a:t>
+            </a:r>
+            <a:r>
+              <a:rPr sz="900">
+                <a:solidFill>
+                  <a:srgbClr val="94A3B8"/>
+                </a:solidFill>
+                <a:latin typeface="Segoe UI"/>
+              </a:rPr>
+              <a:t>Executes within existing Query Lambdas in ~120ms with zero extra infrastructure overhead.</a:t>
+            </a:r>
+          </a:p>
+          <a:p>
+            <a:pPr>
+              <a:spcBef>
+                <a:spcPts val="600"/>
+              </a:spcBef>
+              <a:defRPr sz="950" b="1">
+                <a:solidFill>
+                  <a:srgbClr val="FF9900"/>
+                </a:solidFill>
+                <a:latin typeface="Segoe UI"/>
+              </a:defRPr>
+            </a:pPr>
+            <a:r>
+              <a:t>Dynamic Ingress: </a:t>
+            </a:r>
+            <a:r>
+              <a:rPr sz="900">
+                <a:solidFill>
+                  <a:srgbClr val="94A3B8"/>
+                </a:solidFill>
+                <a:latin typeface="Segoe UI"/>
+              </a:rPr>
+              <a:t>Activated seamlessly via `?format=pdf` query parameter across Document, Download, and Version APIs.</a:t>
+            </a:r>
+          </a:p>
+        </p:txBody>
+      </p:sp>
+      <p:sp>
+        <p:nvSpPr>
+          <p:cNvPr id="7" name="Rounded Rectangle 6"/>
+          <p:cNvSpPr/>
+          <p:nvPr/>
+        </p:nvSpPr>
+        <p:spPr>
+          <a:xfrm>
+            <a:off x="4429353" y="1508760"/>
+            <a:ext cx="3332073" cy="3429000"/>
+          </a:xfrm>
+          <a:prstGeom prst="roundRect">
+            <a:avLst/>
+          </a:prstGeom>
+          <a:solidFill>
+            <a:srgbClr val="1E293B"/>
+          </a:solidFill>
+          <a:ln w="12700">
+            <a:solidFill>
+              <a:srgbClr val="334155"/>
+            </a:solidFill>
+          </a:ln>
+        </p:spPr>
+        <p:style>
+          <a:lnRef idx="1">
+            <a:schemeClr val="accent1"/>
+          </a:lnRef>
+          <a:fillRef idx="3">
+            <a:schemeClr val="accent1"/>
+          </a:fillRef>
+          <a:effectRef idx="2">
+            <a:schemeClr val="accent1"/>
+          </a:effectRef>
+          <a:fontRef idx="minor">
+            <a:schemeClr val="lt1"/>
+          </a:fontRef>
+        </p:style>
+        <p:txBody>
+          <a:bodyPr rtlCol="0" anchor="ctr"/>
+          <a:lstStyle/>
+          <a:p>
+            <a:pPr algn="ctr"/>
+          </a:p>
+        </p:txBody>
+      </p:sp>
+      <p:sp>
+        <p:nvSpPr>
+          <p:cNvPr id="8" name="TextBox 7"/>
+          <p:cNvSpPr txBox="1"/>
+          <p:nvPr/>
+        </p:nvSpPr>
+        <p:spPr>
+          <a:xfrm>
+            <a:off x="4612233" y="1691640"/>
+            <a:ext cx="2966313" cy="3063240"/>
+          </a:xfrm>
+          <a:prstGeom prst="rect">
+            <a:avLst/>
+          </a:prstGeom>
+          <a:noFill/>
+        </p:spPr>
+        <p:txBody>
+          <a:bodyPr wrap="square">
+            <a:spAutoFit/>
+          </a:bodyPr>
+          <a:lstStyle/>
+          <a:p>
+            <a:pPr>
+              <a:defRPr sz="1200" b="1">
+                <a:solidFill>
+                  <a:srgbClr val="34D399"/>
+                </a:solidFill>
+                <a:latin typeface="Segoe UI"/>
+              </a:defRPr>
+            </a:pPr>
+            <a:r>
+              <a:t>🔒 Authority &amp; Derivative Cache</a:t>
+            </a:r>
+          </a:p>
+          <a:p>
+            <a:pPr>
+              <a:spcBef>
+                <a:spcPts val="600"/>
+              </a:spcBef>
+              <a:defRPr sz="950" b="1">
+                <a:solidFill>
+                  <a:srgbClr val="34D399"/>
+                </a:solidFill>
+                <a:latin typeface="Segoe UI"/>
+              </a:defRPr>
+            </a:pPr>
+            <a:r>
+              <a:t>Deterministic S3 Keying: </a:t>
+            </a:r>
+            <a:r>
+              <a:rPr sz="900">
+                <a:solidFill>
+                  <a:srgbClr val="94A3B8"/>
+                </a:solidFill>
+                <a:latin typeface="Segoe UI"/>
+              </a:rPr>
+              <a:t>Cached under `derivatives/{class}/{id}/{s3_version_id}.pdf` for instant O(1) cache hits.</a:t>
+            </a:r>
+          </a:p>
+          <a:p>
+            <a:pPr>
+              <a:spcBef>
+                <a:spcPts val="600"/>
+              </a:spcBef>
+              <a:defRPr sz="950" b="1">
+                <a:solidFill>
+                  <a:srgbClr val="34D399"/>
+                </a:solidFill>
+                <a:latin typeface="Segoe UI"/>
+              </a:defRPr>
+            </a:pPr>
+            <a:r>
+              <a:t>WORM Boundary Invariant: </a:t>
+            </a:r>
+            <a:r>
+              <a:rPr sz="900">
+                <a:solidFill>
+                  <a:srgbClr val="94A3B8"/>
+                </a:solidFill>
+                <a:latin typeface="Segoe UI"/>
+              </a:rPr>
+              <a:t>Conversions never mutate canonical S3 object versions or DynamoDB active control pointers.</a:t>
+            </a:r>
+          </a:p>
+          <a:p>
+            <a:pPr>
+              <a:spcBef>
+                <a:spcPts val="600"/>
+              </a:spcBef>
+              <a:defRPr sz="950" b="1">
+                <a:solidFill>
+                  <a:srgbClr val="34D399"/>
+                </a:solidFill>
+                <a:latin typeface="Segoe UI"/>
+              </a:defRPr>
+            </a:pPr>
+            <a:r>
+              <a:t>Origin Metadata Tracking: </a:t>
+            </a:r>
+            <a:r>
+              <a:rPr sz="900">
+                <a:solidFill>
+                  <a:srgbClr val="94A3B8"/>
+                </a:solidFill>
+                <a:latin typeface="Segoe UI"/>
+              </a:rPr>
+              <a:t>S3 user metadata tags (`x-amz-meta-origin-s3-version-id`, `x-amz-meta-converted-by`) guarantee end-to-end lineage.</a:t>
+            </a:r>
+          </a:p>
+        </p:txBody>
+      </p:sp>
+      <p:sp>
+        <p:nvSpPr>
+          <p:cNvPr id="9" name="Rounded Rectangle 8"/>
+          <p:cNvSpPr/>
+          <p:nvPr/>
+        </p:nvSpPr>
+        <p:spPr>
+          <a:xfrm>
+            <a:off x="8127186" y="1508760"/>
+            <a:ext cx="3332073" cy="3429000"/>
+          </a:xfrm>
+          <a:prstGeom prst="roundRect">
+            <a:avLst/>
+          </a:prstGeom>
+          <a:solidFill>
+            <a:srgbClr val="1E293B"/>
+          </a:solidFill>
+          <a:ln w="12700">
+            <a:solidFill>
+              <a:srgbClr val="334155"/>
+            </a:solidFill>
+          </a:ln>
+        </p:spPr>
+        <p:style>
+          <a:lnRef idx="1">
+            <a:schemeClr val="accent1"/>
+          </a:lnRef>
+          <a:fillRef idx="3">
+            <a:schemeClr val="accent1"/>
+          </a:fillRef>
+          <a:effectRef idx="2">
+            <a:schemeClr val="accent1"/>
+          </a:effectRef>
+          <a:fontRef idx="minor">
+            <a:schemeClr val="lt1"/>
+          </a:fontRef>
+        </p:style>
+        <p:txBody>
+          <a:bodyPr rtlCol="0" anchor="ctr"/>
+          <a:lstStyle/>
+          <a:p>
+            <a:pPr algn="ctr"/>
+          </a:p>
+        </p:txBody>
+      </p:sp>
+      <p:sp>
+        <p:nvSpPr>
+          <p:cNvPr id="10" name="TextBox 9"/>
+          <p:cNvSpPr txBox="1"/>
+          <p:nvPr/>
+        </p:nvSpPr>
+        <p:spPr>
+          <a:xfrm>
+            <a:off x="8310066" y="1691640"/>
+            <a:ext cx="2966313" cy="3063240"/>
+          </a:xfrm>
+          <a:prstGeom prst="rect">
+            <a:avLst/>
+          </a:prstGeom>
+          <a:noFill/>
+        </p:spPr>
+        <p:txBody>
+          <a:bodyPr wrap="square">
+            <a:spAutoFit/>
+          </a:bodyPr>
+          <a:lstStyle/>
+          <a:p>
+            <a:pPr>
+              <a:defRPr sz="1200" b="1">
+                <a:solidFill>
+                  <a:srgbClr val="C084FC"/>
+                </a:solidFill>
+                <a:latin typeface="Segoe UI"/>
+              </a:defRPr>
+            </a:pPr>
+            <a:r>
+              <a:t>💰 FinOps &amp; Lifecycle Rules</a:t>
+            </a:r>
+          </a:p>
+          <a:p>
+            <a:pPr>
+              <a:spcBef>
+                <a:spcPts val="600"/>
+              </a:spcBef>
+              <a:defRPr sz="950" b="1">
+                <a:solidFill>
+                  <a:srgbClr val="C084FC"/>
+                </a:solidFill>
+                <a:latin typeface="Segoe UI"/>
+              </a:defRPr>
+            </a:pPr>
+            <a:r>
+              <a:t>14-Day Auto-Purge: </a:t>
+            </a:r>
+            <a:r>
+              <a:rPr sz="900">
+                <a:solidFill>
+                  <a:srgbClr val="94A3B8"/>
+                </a:solidFill>
+                <a:latin typeface="Segoe UI"/>
+              </a:rPr>
+              <a:t>Automated S3 Lifecycle Rule permanently expires derivative cache files after 14 days to prevent storage bloat.</a:t>
+            </a:r>
+          </a:p>
+          <a:p>
+            <a:pPr>
+              <a:spcBef>
+                <a:spcPts val="600"/>
+              </a:spcBef>
+              <a:defRPr sz="950" b="1">
+                <a:solidFill>
+                  <a:srgbClr val="C084FC"/>
+                </a:solidFill>
+                <a:latin typeface="Segoe UI"/>
+              </a:defRPr>
+            </a:pPr>
+            <a:r>
+              <a:t>80%+ Cache Hit Ratio: </a:t>
+            </a:r>
+            <a:r>
+              <a:rPr sz="900">
+                <a:solidFill>
+                  <a:srgbClr val="94A3B8"/>
+                </a:solidFill>
+                <a:latin typeface="Segoe UI"/>
+              </a:rPr>
+              <a:t>Frequent downloads reuse cached derivative S3 presigned URLs without triggering redundant compute.</a:t>
+            </a:r>
+          </a:p>
+          <a:p>
+            <a:pPr>
+              <a:spcBef>
+                <a:spcPts val="600"/>
+              </a:spcBef>
+              <a:defRPr sz="950" b="1">
+                <a:solidFill>
+                  <a:srgbClr val="C084FC"/>
+                </a:solidFill>
+                <a:latin typeface="Segoe UI"/>
+              </a:defRPr>
+            </a:pPr>
+            <a:r>
+              <a:t>Graviton Cost Efficiency: </a:t>
+            </a:r>
+            <a:r>
+              <a:rPr sz="900">
+                <a:solidFill>
+                  <a:srgbClr val="94A3B8"/>
+                </a:solidFill>
+                <a:latin typeface="Segoe UI"/>
+              </a:rPr>
+              <a:t>ARM64 architecture provides 20% lower price-per-millisecond than x86_64.</a:t>
+            </a:r>
+          </a:p>
+        </p:txBody>
+      </p:sp>
+      <p:sp>
+        <p:nvSpPr>
+          <p:cNvPr id="11" name="Rounded Rectangle 10"/>
+          <p:cNvSpPr/>
+          <p:nvPr/>
+        </p:nvSpPr>
+        <p:spPr>
+          <a:xfrm>
+            <a:off x="731520" y="5120640"/>
+            <a:ext cx="10728655" cy="1097280"/>
+          </a:xfrm>
+          <a:prstGeom prst="roundRect">
+            <a:avLst/>
+          </a:prstGeom>
+          <a:solidFill>
+            <a:srgbClr val="1E293B"/>
+          </a:solidFill>
+          <a:ln w="12700">
+            <a:solidFill>
+              <a:srgbClr val="334155"/>
+            </a:solidFill>
+          </a:ln>
+        </p:spPr>
+        <p:style>
+          <a:lnRef idx="1">
+            <a:schemeClr val="accent1"/>
+          </a:lnRef>
+          <a:fillRef idx="3">
+            <a:schemeClr val="accent1"/>
+          </a:fillRef>
+          <a:effectRef idx="2">
+            <a:schemeClr val="accent1"/>
+          </a:effectRef>
+          <a:fontRef idx="minor">
+            <a:schemeClr val="lt1"/>
+          </a:fontRef>
+        </p:style>
+        <p:txBody>
+          <a:bodyPr rtlCol="0" anchor="ctr"/>
+          <a:lstStyle/>
+          <a:p>
+            <a:pPr algn="ctr"/>
+          </a:p>
+        </p:txBody>
+      </p:sp>
+      <p:sp>
+        <p:nvSpPr>
+          <p:cNvPr id="12" name="TextBox 11"/>
+          <p:cNvSpPr txBox="1"/>
+          <p:nvPr/>
+        </p:nvSpPr>
+        <p:spPr>
+          <a:xfrm>
+            <a:off x="914400" y="5193792"/>
+            <a:ext cx="10362895" cy="914400"/>
+          </a:xfrm>
+          <a:prstGeom prst="rect">
+            <a:avLst/>
+          </a:prstGeom>
+          <a:noFill/>
+        </p:spPr>
+        <p:txBody>
+          <a:bodyPr wrap="square">
+            <a:spAutoFit/>
+          </a:bodyPr>
+          <a:lstStyle/>
+          <a:p>
+            <a:pPr>
               <a:defRPr sz="1100" b="1">
                 <a:solidFill>
-                  <a:srgbClr val="C084FC"/>
-                </a:solidFill>
-                <a:latin typeface="Segoe UI"/>
-              </a:defRPr>
-            </a:pPr>
-            <a:r>
-              <a:t>Search Querying &amp; Observability Highlights:</a:t>
-            </a:r>
-          </a:p>
-        </p:txBody>
-      </p:sp>
-      <p:sp>
-        <p:nvSpPr>
-          <p:cNvPr id="7" name="Rectangle 6"/>
+                  <a:srgbClr val="FF9900"/>
+                </a:solidFill>
+                <a:latin typeface="Segoe UI"/>
+              </a:defRPr>
+            </a:pPr>
+            <a:r>
+              <a:t>End-to-End Client Delivery Workflow:</a:t>
+            </a:r>
+          </a:p>
+          <a:p>
+            <a:pPr>
+              <a:spcBef>
+                <a:spcPts val="200"/>
+              </a:spcBef>
+              <a:defRPr sz="950">
+                <a:solidFill>
+                  <a:srgbClr val="F8FAFC"/>
+                </a:solidFill>
+                <a:latin typeface="Segoe UI"/>
+              </a:defRPr>
+            </a:pPr>
+            <a:r>
+              <a:t>1. Client calls `GET /documents/{id}?format=pdf` → 2. Query Lambda checks S3 cache → 3. If cache miss: fetches raw JPEG/PNG, converts in memory via Graviton, writes derivative with origin metadata to S3 → 4. Returns 15-min presigned download URL for instant PDF streaming.</a:t>
+            </a:r>
+          </a:p>
+        </p:txBody>
+      </p:sp>
+      <p:sp>
+        <p:nvSpPr>
+          <p:cNvPr id="13" name="Rectangle 12"/>
           <p:cNvSpPr/>
           <p:nvPr/>
         </p:nvSpPr>
@@ -9075,7 +9560,7 @@
       </p:sp>
       <p:sp>
         <p:nvSpPr>
-          <p:cNvPr id="8" name="TextBox 7"/>
+          <p:cNvPr id="14" name="TextBox 13"/>
           <p:cNvSpPr txBox="1"/>
           <p:nvPr/>
         </p:nvSpPr>
@@ -9111,7 +9596,7 @@
       </p:sp>
       <p:sp>
         <p:nvSpPr>
-          <p:cNvPr id="9" name="TextBox 8"/>
+          <p:cNvPr id="15" name="TextBox 14"/>
           <p:cNvSpPr txBox="1"/>
           <p:nvPr/>
         </p:nvSpPr>
@@ -9140,7 +9625,7 @@
               </a:defRPr>
             </a:pPr>
             <a:r>
-              <a:t>18 / 22</a:t>
+              <a:t>18 / 23</a:t>
             </a:r>
           </a:p>
         </p:txBody>
@@ -9202,7 +9687,7 @@
               </a:defRPr>
             </a:pPr>
             <a:r>
-              <a:t>CLIENT INTEGRATION ARCHITECTURE</a:t>
+              <a:t>API EXECUTION SEQUENCE</a:t>
             </a:r>
           </a:p>
         </p:txBody>
@@ -9238,7 +9723,7 @@
               </a:defRPr>
             </a:pPr>
             <a:r>
-              <a:t>Serverless Web Portal &amp; Client Integration Architecture</a:t>
+              <a:t>Sequence Deep Dive: OpenSearch Search &amp; Deep Health Probe</a:t>
             </a:r>
           </a:p>
         </p:txBody>
@@ -9274,7 +9759,7 @@
               </a:defRPr>
             </a:pPr>
             <a:r>
-              <a:t>CloudFront + S3 SPA, Cognito JWT Authentication &amp; Client-Side SHA256 Checksums</a:t>
+              <a:t>API Sequences 15 &amp; 01: POST /v1/search &amp; GET /health</a:t>
             </a:r>
           </a:p>
         </p:txBody>
@@ -9287,8 +9772,8 @@
         </p:nvSpPr>
         <p:spPr>
           <a:xfrm>
-            <a:off x="8229600" y="1508760"/>
-            <a:ext cx="3230575" cy="4709160"/>
+            <a:off x="731520" y="5120640"/>
+            <a:ext cx="10728655" cy="1097280"/>
           </a:xfrm>
           <a:prstGeom prst="roundRect">
             <a:avLst/>
@@ -9332,8 +9817,8 @@
         </p:nvSpPr>
         <p:spPr>
           <a:xfrm>
-            <a:off x="8412480" y="1691640"/>
-            <a:ext cx="2864815" cy="4343400"/>
+            <a:off x="914400" y="5193792"/>
+            <a:ext cx="10362895" cy="914400"/>
           </a:xfrm>
           <a:prstGeom prst="rect">
             <a:avLst/>
@@ -9347,115 +9832,35 @@
           <a:lstStyle/>
           <a:p>
             <a:pPr>
-              <a:defRPr sz="1300" b="1">
-                <a:solidFill>
-                  <a:srgbClr val="FF9900"/>
-                </a:solidFill>
-                <a:latin typeface="Segoe UI"/>
-              </a:defRPr>
-            </a:pPr>
-            <a:r>
-              <a:t>Integration Highlights</a:t>
+              <a:defRPr sz="1100" b="1">
+                <a:solidFill>
+                  <a:srgbClr val="C084FC"/>
+                </a:solidFill>
+                <a:latin typeface="Segoe UI"/>
+              </a:defRPr>
+            </a:pPr>
+            <a:r>
+              <a:t>Search Querying &amp; Observability Highlights:</a:t>
             </a:r>
           </a:p>
           <a:p>
             <a:pPr>
               <a:spcBef>
-                <a:spcPts val="600"/>
+                <a:spcPts val="200"/>
               </a:spcBef>
-              <a:defRPr sz="1000" b="1">
-                <a:solidFill>
-                  <a:srgbClr val="38BDF8"/>
-                </a:solidFill>
-                <a:latin typeface="Segoe UI"/>
-              </a:defRPr>
-            </a:pPr>
-            <a:r>
-              <a:t>• 1-Click Persona Simulator: </a:t>
-            </a:r>
-            <a:r>
-              <a:rPr sz="950">
-                <a:solidFill>
-                  <a:srgbClr val="94A3B8"/>
-                </a:solidFill>
-                <a:latin typeface="Segoe UI"/>
-              </a:rPr>
-              <a:t>Instant token generation for Document.Admin, Document.Writer, Document.Reader, and Compliance Officer.</a:t>
-            </a:r>
-          </a:p>
-          <a:p>
-            <a:pPr>
-              <a:spcBef>
-                <a:spcPts val="600"/>
-              </a:spcBef>
-              <a:defRPr sz="1000" b="1">
-                <a:solidFill>
-                  <a:srgbClr val="38BDF8"/>
-                </a:solidFill>
-                <a:latin typeface="Segoe UI"/>
-              </a:defRPr>
-            </a:pPr>
-            <a:r>
-              <a:t>• Automatic Token Ingress: </a:t>
-            </a:r>
-            <a:r>
-              <a:rPr sz="950">
-                <a:solidFill>
-                  <a:srgbClr val="94A3B8"/>
-                </a:solidFill>
-                <a:latin typeface="Segoe UI"/>
-              </a:rPr>
-              <a:t>Signs all HTTP requests with Cognito OAuth 2.0 / OpenID Connect JWT tokens.</a:t>
-            </a:r>
-          </a:p>
-          <a:p>
-            <a:pPr>
-              <a:spcBef>
-                <a:spcPts val="600"/>
-              </a:spcBef>
-              <a:defRPr sz="1000" b="1">
-                <a:solidFill>
-                  <a:srgbClr val="38BDF8"/>
-                </a:solidFill>
-                <a:latin typeface="Segoe UI"/>
-              </a:defRPr>
-            </a:pPr>
-            <a:r>
-              <a:t>• Bimodal File Upload UI: </a:t>
-            </a:r>
-            <a:r>
-              <a:rPr sz="950">
-                <a:solidFill>
-                  <a:srgbClr val="94A3B8"/>
-                </a:solidFill>
-                <a:latin typeface="Segoe UI"/>
-              </a:rPr>
-              <a:t>Direct S3 presigned upload with client-side SHA256 hashing and inline binary upload (&lt; 4 MiB).</a:t>
-            </a:r>
-          </a:p>
-          <a:p>
-            <a:pPr>
-              <a:spcBef>
-                <a:spcPts val="600"/>
-              </a:spcBef>
-              <a:defRPr sz="1000" b="1">
-                <a:solidFill>
-                  <a:srgbClr val="38BDF8"/>
-                </a:solidFill>
-                <a:latin typeface="Segoe UI"/>
-              </a:defRPr>
-            </a:pPr>
-            <a:r>
-              <a:t>• OpenSearch Discovery: </a:t>
-            </a:r>
-            <a:r>
-              <a:rPr sz="950">
-                <a:solidFill>
-                  <a:srgbClr val="94A3B8"/>
-                </a:solidFill>
-                <a:latin typeface="Segoe UI"/>
-              </a:rPr>
-              <a:t>Real-time faceted exploration with dynamic status and attribute filters.</a:t>
+              <a:defRPr sz="900">
+                <a:solidFill>
+                  <a:srgbClr val="F8FAFC"/>
+                </a:solidFill>
+                <a:latin typeface="Segoe UI"/>
+              </a:defRPr>
+            </a:pPr>
+            <a:r>
+              <a:t>• Search Pipeline (15): OpenSearch Serverless collection executed with multi-attribute filtering and pagination. Bypasses primary S3/DynamoDB datastores for zero read load impact on transactional plane.</a:t>
+            </a:r>
+            <a:br/>
+            <a:r>
+              <a:t>• Deep Health Monitoring (01): Verifies active connectivity to DynamoDB, S3 Document Bucket, S3 Audit Bucket, SQS Queue, and OpenSearch Serverless collection in a single diagnostic sweep.</a:t>
             </a:r>
           </a:p>
         </p:txBody>
@@ -9570,7 +9975,7 @@
               </a:defRPr>
             </a:pPr>
             <a:r>
-              <a:t>19 / 22</a:t>
+              <a:t>19 / 23</a:t>
             </a:r>
           </a:p>
         </p:txBody>
@@ -10173,7 +10578,7 @@
               </a:defRPr>
             </a:pPr>
             <a:r>
-              <a:t>2 / 22</a:t>
+              <a:t>2 / 23</a:t>
             </a:r>
           </a:p>
         </p:txBody>
@@ -10212,8 +10617,161 @@
         </p:nvSpPr>
         <p:spPr>
           <a:xfrm>
-            <a:off x="914400" y="1691640"/>
-            <a:ext cx="5120640" cy="4389120"/>
+            <a:off x="731520" y="365760"/>
+            <a:ext cx="7315200" cy="274320"/>
+          </a:xfrm>
+          <a:prstGeom prst="rect">
+            <a:avLst/>
+          </a:prstGeom>
+          <a:noFill/>
+        </p:spPr>
+        <p:txBody>
+          <a:bodyPr wrap="square" lIns="0" tIns="0" rIns="0" bIns="0">
+            <a:spAutoFit/>
+          </a:bodyPr>
+          <a:lstStyle/>
+          <a:p>
+            <a:pPr>
+              <a:defRPr sz="950" b="1">
+                <a:solidFill>
+                  <a:srgbClr val="38BDF8"/>
+                </a:solidFill>
+                <a:latin typeface="Segoe UI"/>
+              </a:defRPr>
+            </a:pPr>
+            <a:r>
+              <a:t>CLIENT INTEGRATION ARCHITECTURE</a:t>
+            </a:r>
+          </a:p>
+        </p:txBody>
+      </p:sp>
+      <p:sp>
+        <p:nvSpPr>
+          <p:cNvPr id="3" name="TextBox 2"/>
+          <p:cNvSpPr txBox="1"/>
+          <p:nvPr/>
+        </p:nvSpPr>
+        <p:spPr>
+          <a:xfrm>
+            <a:off x="731520" y="621792"/>
+            <a:ext cx="10698480" cy="502920"/>
+          </a:xfrm>
+          <a:prstGeom prst="rect">
+            <a:avLst/>
+          </a:prstGeom>
+          <a:noFill/>
+        </p:spPr>
+        <p:txBody>
+          <a:bodyPr wrap="square" lIns="0" tIns="0" rIns="0" bIns="0">
+            <a:spAutoFit/>
+          </a:bodyPr>
+          <a:lstStyle/>
+          <a:p>
+            <a:pPr>
+              <a:defRPr sz="2000" b="1">
+                <a:solidFill>
+                  <a:srgbClr val="F8FAFC"/>
+                </a:solidFill>
+                <a:latin typeface="Segoe UI"/>
+              </a:defRPr>
+            </a:pPr>
+            <a:r>
+              <a:t>Serverless Web Portal &amp; Client Integration Architecture</a:t>
+            </a:r>
+          </a:p>
+        </p:txBody>
+      </p:sp>
+      <p:sp>
+        <p:nvSpPr>
+          <p:cNvPr id="4" name="TextBox 3"/>
+          <p:cNvSpPr txBox="1"/>
+          <p:nvPr/>
+        </p:nvSpPr>
+        <p:spPr>
+          <a:xfrm>
+            <a:off x="731520" y="1115568"/>
+            <a:ext cx="10698480" cy="320040"/>
+          </a:xfrm>
+          <a:prstGeom prst="rect">
+            <a:avLst/>
+          </a:prstGeom>
+          <a:noFill/>
+        </p:spPr>
+        <p:txBody>
+          <a:bodyPr wrap="square" lIns="0" tIns="0" rIns="0" bIns="0">
+            <a:spAutoFit/>
+          </a:bodyPr>
+          <a:lstStyle/>
+          <a:p>
+            <a:pPr>
+              <a:defRPr sz="1100">
+                <a:solidFill>
+                  <a:srgbClr val="94A3B8"/>
+                </a:solidFill>
+                <a:latin typeface="Segoe UI"/>
+              </a:defRPr>
+            </a:pPr>
+            <a:r>
+              <a:t>CloudFront + S3 SPA, Cognito JWT Authentication &amp; Client-Side SHA256 Checksums</a:t>
+            </a:r>
+          </a:p>
+        </p:txBody>
+      </p:sp>
+      <p:sp>
+        <p:nvSpPr>
+          <p:cNvPr id="5" name="Rounded Rectangle 4"/>
+          <p:cNvSpPr/>
+          <p:nvPr/>
+        </p:nvSpPr>
+        <p:spPr>
+          <a:xfrm>
+            <a:off x="8229600" y="1508760"/>
+            <a:ext cx="3230575" cy="4709160"/>
+          </a:xfrm>
+          <a:prstGeom prst="roundRect">
+            <a:avLst/>
+          </a:prstGeom>
+          <a:solidFill>
+            <a:srgbClr val="1E293B"/>
+          </a:solidFill>
+          <a:ln w="12700">
+            <a:solidFill>
+              <a:srgbClr val="334155"/>
+            </a:solidFill>
+          </a:ln>
+        </p:spPr>
+        <p:style>
+          <a:lnRef idx="1">
+            <a:schemeClr val="accent1"/>
+          </a:lnRef>
+          <a:fillRef idx="3">
+            <a:schemeClr val="accent1"/>
+          </a:fillRef>
+          <a:effectRef idx="2">
+            <a:schemeClr val="accent1"/>
+          </a:effectRef>
+          <a:fontRef idx="minor">
+            <a:schemeClr val="lt1"/>
+          </a:fontRef>
+        </p:style>
+        <p:txBody>
+          <a:bodyPr rtlCol="0" anchor="ctr"/>
+          <a:lstStyle/>
+          <a:p>
+            <a:pPr algn="ctr"/>
+          </a:p>
+        </p:txBody>
+      </p:sp>
+      <p:sp>
+        <p:nvSpPr>
+          <p:cNvPr id="6" name="TextBox 5"/>
+          <p:cNvSpPr txBox="1"/>
+          <p:nvPr/>
+        </p:nvSpPr>
+        <p:spPr>
+          <a:xfrm>
+            <a:off x="8412480" y="1691640"/>
+            <a:ext cx="2864815" cy="4343400"/>
           </a:xfrm>
           <a:prstGeom prst="rect">
             <a:avLst/>
@@ -10229,6 +10787,416 @@
             <a:pPr>
               <a:defRPr sz="1300" b="1">
                 <a:solidFill>
+                  <a:srgbClr val="FF9900"/>
+                </a:solidFill>
+                <a:latin typeface="Segoe UI"/>
+              </a:defRPr>
+            </a:pPr>
+            <a:r>
+              <a:t>Integration Highlights</a:t>
+            </a:r>
+          </a:p>
+          <a:p>
+            <a:pPr>
+              <a:spcBef>
+                <a:spcPts val="400"/>
+              </a:spcBef>
+              <a:defRPr sz="950" b="1">
+                <a:solidFill>
+                  <a:srgbClr val="38BDF8"/>
+                </a:solidFill>
+                <a:latin typeface="Segoe UI"/>
+              </a:defRPr>
+            </a:pPr>
+            <a:r>
+              <a:t>• 1-Click Persona Simulator: </a:t>
+            </a:r>
+            <a:r>
+              <a:rPr sz="850">
+                <a:solidFill>
+                  <a:srgbClr val="94A3B8"/>
+                </a:solidFill>
+                <a:latin typeface="Segoe UI"/>
+              </a:rPr>
+              <a:t>Instant token generation for Document.Admin, Document.Writer, Document.Reader, and Compliance Officer.</a:t>
+            </a:r>
+          </a:p>
+          <a:p>
+            <a:pPr>
+              <a:spcBef>
+                <a:spcPts val="400"/>
+              </a:spcBef>
+              <a:defRPr sz="950" b="1">
+                <a:solidFill>
+                  <a:srgbClr val="38BDF8"/>
+                </a:solidFill>
+                <a:latin typeface="Segoe UI"/>
+              </a:defRPr>
+            </a:pPr>
+            <a:r>
+              <a:t>• Automatic Token Ingress: </a:t>
+            </a:r>
+            <a:r>
+              <a:rPr sz="850">
+                <a:solidFill>
+                  <a:srgbClr val="94A3B8"/>
+                </a:solidFill>
+                <a:latin typeface="Segoe UI"/>
+              </a:rPr>
+              <a:t>Signs all HTTP requests with Cognito OAuth 2.0 / OpenID Connect JWT tokens.</a:t>
+            </a:r>
+          </a:p>
+          <a:p>
+            <a:pPr>
+              <a:spcBef>
+                <a:spcPts val="400"/>
+              </a:spcBef>
+              <a:defRPr sz="950" b="1">
+                <a:solidFill>
+                  <a:srgbClr val="38BDF8"/>
+                </a:solidFill>
+                <a:latin typeface="Segoe UI"/>
+              </a:defRPr>
+            </a:pPr>
+            <a:r>
+              <a:t>• Bimodal File Upload UI: </a:t>
+            </a:r>
+            <a:r>
+              <a:rPr sz="850">
+                <a:solidFill>
+                  <a:srgbClr val="94A3B8"/>
+                </a:solidFill>
+                <a:latin typeface="Segoe UI"/>
+              </a:rPr>
+              <a:t>Direct S3 presigned upload with client-side SHA256 hashing and inline binary upload (&lt; 4 MiB).</a:t>
+            </a:r>
+          </a:p>
+          <a:p>
+            <a:pPr>
+              <a:spcBef>
+                <a:spcPts val="400"/>
+              </a:spcBef>
+              <a:defRPr sz="950" b="1">
+                <a:solidFill>
+                  <a:srgbClr val="38BDF8"/>
+                </a:solidFill>
+                <a:latin typeface="Segoe UI"/>
+              </a:defRPr>
+            </a:pPr>
+            <a:r>
+              <a:t>• On-Demand PDF Delivery: </a:t>
+            </a:r>
+            <a:r>
+              <a:rPr sz="850">
+                <a:solidFill>
+                  <a:srgbClr val="94A3B8"/>
+                </a:solidFill>
+                <a:latin typeface="Segoe UI"/>
+              </a:rPr>
+              <a:t>Dynamic in-browser PDF download button with automatic on-the-fly image conversion.</a:t>
+            </a:r>
+          </a:p>
+          <a:p>
+            <a:pPr>
+              <a:spcBef>
+                <a:spcPts val="400"/>
+              </a:spcBef>
+              <a:defRPr sz="950" b="1">
+                <a:solidFill>
+                  <a:srgbClr val="38BDF8"/>
+                </a:solidFill>
+                <a:latin typeface="Segoe UI"/>
+              </a:defRPr>
+            </a:pPr>
+            <a:r>
+              <a:t>• OpenSearch Discovery: </a:t>
+            </a:r>
+            <a:r>
+              <a:rPr sz="850">
+                <a:solidFill>
+                  <a:srgbClr val="94A3B8"/>
+                </a:solidFill>
+                <a:latin typeface="Segoe UI"/>
+              </a:rPr>
+              <a:t>Real-time faceted exploration with dynamic status and attribute filters.</a:t>
+            </a:r>
+          </a:p>
+        </p:txBody>
+      </p:sp>
+      <p:sp>
+        <p:nvSpPr>
+          <p:cNvPr id="7" name="Rectangle 6"/>
+          <p:cNvSpPr/>
+          <p:nvPr/>
+        </p:nvSpPr>
+        <p:spPr>
+          <a:xfrm>
+            <a:off x="731520" y="6446520"/>
+            <a:ext cx="10728655" cy="13716"/>
+          </a:xfrm>
+          <a:prstGeom prst="rect">
+            <a:avLst/>
+          </a:prstGeom>
+          <a:solidFill>
+            <a:srgbClr val="334155"/>
+          </a:solidFill>
+          <a:ln>
+            <a:noFill/>
+          </a:ln>
+        </p:spPr>
+        <p:style>
+          <a:lnRef idx="1">
+            <a:schemeClr val="accent1"/>
+          </a:lnRef>
+          <a:fillRef idx="3">
+            <a:schemeClr val="accent1"/>
+          </a:fillRef>
+          <a:effectRef idx="2">
+            <a:schemeClr val="accent1"/>
+          </a:effectRef>
+          <a:fontRef idx="minor">
+            <a:schemeClr val="lt1"/>
+          </a:fontRef>
+        </p:style>
+        <p:txBody>
+          <a:bodyPr rtlCol="0" anchor="ctr"/>
+          <a:lstStyle/>
+          <a:p>
+            <a:pPr algn="ctr"/>
+          </a:p>
+        </p:txBody>
+      </p:sp>
+      <p:sp>
+        <p:nvSpPr>
+          <p:cNvPr id="8" name="TextBox 7"/>
+          <p:cNvSpPr txBox="1"/>
+          <p:nvPr/>
+        </p:nvSpPr>
+        <p:spPr>
+          <a:xfrm>
+            <a:off x="731520" y="6510528"/>
+            <a:ext cx="7772400" cy="228600"/>
+          </a:xfrm>
+          <a:prstGeom prst="rect">
+            <a:avLst/>
+          </a:prstGeom>
+          <a:noFill/>
+        </p:spPr>
+        <p:txBody>
+          <a:bodyPr wrap="none" lIns="0" tIns="0" rIns="0" bIns="0">
+            <a:spAutoFit/>
+          </a:bodyPr>
+          <a:lstStyle/>
+          <a:p>
+            <a:pPr>
+              <a:defRPr sz="850">
+                <a:solidFill>
+                  <a:srgbClr val="64748B"/>
+                </a:solidFill>
+                <a:latin typeface="Segoe UI"/>
+              </a:defRPr>
+            </a:pPr>
+            <a:r>
+              <a:t>AWS Document Management Platform • Solution Architecture &amp; Sequence Specification</a:t>
+            </a:r>
+          </a:p>
+        </p:txBody>
+      </p:sp>
+      <p:sp>
+        <p:nvSpPr>
+          <p:cNvPr id="9" name="TextBox 8"/>
+          <p:cNvSpPr txBox="1"/>
+          <p:nvPr/>
+        </p:nvSpPr>
+        <p:spPr>
+          <a:xfrm>
+            <a:off x="9144000" y="6510528"/>
+            <a:ext cx="2316175" cy="228600"/>
+          </a:xfrm>
+          <a:prstGeom prst="rect">
+            <a:avLst/>
+          </a:prstGeom>
+          <a:noFill/>
+        </p:spPr>
+        <p:txBody>
+          <a:bodyPr wrap="none" lIns="0" tIns="0" rIns="0" bIns="0">
+            <a:spAutoFit/>
+          </a:bodyPr>
+          <a:lstStyle/>
+          <a:p>
+            <a:pPr algn="r">
+              <a:defRPr sz="850" b="1">
+                <a:solidFill>
+                  <a:srgbClr val="38BDF8"/>
+                </a:solidFill>
+                <a:latin typeface="Segoe UI"/>
+              </a:defRPr>
+            </a:pPr>
+            <a:r>
+              <a:t>20 / 23</a:t>
+            </a:r>
+          </a:p>
+        </p:txBody>
+      </p:sp>
+    </p:spTree>
+  </p:cSld>
+  <p:clrMapOvr>
+    <a:masterClrMapping/>
+  </p:clrMapOvr>
+</p:sld>
+</file>
+
+<file path=ppt/slides/slide21.xml><?xml version="1.0" encoding="utf-8"?>
+<p:sld xmlns:a="http://schemas.openxmlformats.org/drawingml/2006/main" xmlns:p="http://schemas.openxmlformats.org/presentationml/2006/main" xmlns:r="http://schemas.openxmlformats.org/officeDocument/2006/relationships">
+  <p:cSld>
+    <p:bg>
+      <p:bgPr>
+        <a:solidFill>
+          <a:srgbClr val="0B1120"/>
+        </a:solidFill>
+        <a:effectLst/>
+      </p:bgPr>
+    </p:bg>
+    <p:spTree>
+      <p:nvGrpSpPr>
+        <p:cNvPr id="1" name=""/>
+        <p:cNvGrpSpPr/>
+        <p:nvPr/>
+      </p:nvGrpSpPr>
+      <p:grpSpPr/>
+      <p:sp>
+        <p:nvSpPr>
+          <p:cNvPr id="2" name="TextBox 1"/>
+          <p:cNvSpPr txBox="1"/>
+          <p:nvPr/>
+        </p:nvSpPr>
+        <p:spPr>
+          <a:xfrm>
+            <a:off x="731520" y="365760"/>
+            <a:ext cx="7315200" cy="274320"/>
+          </a:xfrm>
+          <a:prstGeom prst="rect">
+            <a:avLst/>
+          </a:prstGeom>
+          <a:noFill/>
+        </p:spPr>
+        <p:txBody>
+          <a:bodyPr wrap="square" lIns="0" tIns="0" rIns="0" bIns="0">
+            <a:spAutoFit/>
+          </a:bodyPr>
+          <a:lstStyle/>
+          <a:p>
+            <a:pPr>
+              <a:defRPr sz="950" b="1">
+                <a:solidFill>
+                  <a:srgbClr val="38BDF8"/>
+                </a:solidFill>
+                <a:latin typeface="Segoe UI"/>
+              </a:defRPr>
+            </a:pPr>
+            <a:r>
+              <a:t>SECURITY &amp; GOVERNANCE</a:t>
+            </a:r>
+          </a:p>
+        </p:txBody>
+      </p:sp>
+      <p:sp>
+        <p:nvSpPr>
+          <p:cNvPr id="3" name="TextBox 2"/>
+          <p:cNvSpPr txBox="1"/>
+          <p:nvPr/>
+        </p:nvSpPr>
+        <p:spPr>
+          <a:xfrm>
+            <a:off x="731520" y="621792"/>
+            <a:ext cx="10698480" cy="502920"/>
+          </a:xfrm>
+          <a:prstGeom prst="rect">
+            <a:avLst/>
+          </a:prstGeom>
+          <a:noFill/>
+        </p:spPr>
+        <p:txBody>
+          <a:bodyPr wrap="square" lIns="0" tIns="0" rIns="0" bIns="0">
+            <a:spAutoFit/>
+          </a:bodyPr>
+          <a:lstStyle/>
+          <a:p>
+            <a:pPr>
+              <a:defRPr sz="2000" b="1">
+                <a:solidFill>
+                  <a:srgbClr val="F8FAFC"/>
+                </a:solidFill>
+                <a:latin typeface="Segoe UI"/>
+              </a:defRPr>
+            </a:pPr>
+            <a:r>
+              <a:t>Enterprise Security, KMS Cryptography &amp; Fine-Grained RBAC</a:t>
+            </a:r>
+          </a:p>
+        </p:txBody>
+      </p:sp>
+      <p:sp>
+        <p:nvSpPr>
+          <p:cNvPr id="4" name="TextBox 3"/>
+          <p:cNvSpPr txBox="1"/>
+          <p:nvPr/>
+        </p:nvSpPr>
+        <p:spPr>
+          <a:xfrm>
+            <a:off x="731520" y="1115568"/>
+            <a:ext cx="10698480" cy="320040"/>
+          </a:xfrm>
+          <a:prstGeom prst="rect">
+            <a:avLst/>
+          </a:prstGeom>
+          <a:noFill/>
+        </p:spPr>
+        <p:txBody>
+          <a:bodyPr wrap="square" lIns="0" tIns="0" rIns="0" bIns="0">
+            <a:spAutoFit/>
+          </a:bodyPr>
+          <a:lstStyle/>
+          <a:p>
+            <a:pPr>
+              <a:defRPr sz="1100">
+                <a:solidFill>
+                  <a:srgbClr val="94A3B8"/>
+                </a:solidFill>
+                <a:latin typeface="Segoe UI"/>
+              </a:defRPr>
+            </a:pPr>
+            <a:r>
+              <a:t>Cognito JWT Scopes, Customer Managed KMS Keys (CMK) &amp; WORM Immutability</a:t>
+            </a:r>
+          </a:p>
+        </p:txBody>
+      </p:sp>
+      <p:sp>
+        <p:nvSpPr>
+          <p:cNvPr id="5" name="TextBox 4"/>
+          <p:cNvSpPr txBox="1"/>
+          <p:nvPr/>
+        </p:nvSpPr>
+        <p:spPr>
+          <a:xfrm>
+            <a:off x="914400" y="1691640"/>
+            <a:ext cx="5120640" cy="4389120"/>
+          </a:xfrm>
+          <a:prstGeom prst="rect">
+            <a:avLst/>
+          </a:prstGeom>
+          <a:noFill/>
+        </p:spPr>
+        <p:txBody>
+          <a:bodyPr wrap="square">
+            <a:spAutoFit/>
+          </a:bodyPr>
+          <a:lstStyle/>
+          <a:p>
+            <a:pPr>
+              <a:defRPr sz="1300" b="1">
+                <a:solidFill>
                   <a:srgbClr val="38BDF8"/>
                 </a:solidFill>
                 <a:latin typeface="Segoe UI"/>
@@ -10242,7 +11210,7 @@
       </p:sp>
       <p:graphicFrame>
         <p:nvGraphicFramePr>
-          <p:cNvPr id="3" name="Table 2"/>
+          <p:cNvPr id="6" name="Table 5"/>
           <p:cNvGraphicFramePr>
             <a:graphicFrameLocks noGrp="1"/>
           </p:cNvGraphicFramePr>
@@ -11369,7 +12337,7 @@
       </p:graphicFrame>
       <p:sp>
         <p:nvSpPr>
-          <p:cNvPr id="4" name="Rounded Rectangle 3"/>
+          <p:cNvPr id="7" name="Rounded Rectangle 6"/>
           <p:cNvSpPr/>
           <p:nvPr/>
         </p:nvSpPr>
@@ -11414,7 +12382,7 @@
       </p:sp>
       <p:sp>
         <p:nvSpPr>
-          <p:cNvPr id="5" name="TextBox 4"/>
+          <p:cNvPr id="8" name="TextBox 7"/>
           <p:cNvSpPr txBox="1"/>
           <p:nvPr/>
         </p:nvSpPr>
@@ -11578,7 +12546,7 @@
       </p:sp>
       <p:sp>
         <p:nvSpPr>
-          <p:cNvPr id="6" name="Rectangle 5"/>
+          <p:cNvPr id="9" name="Rectangle 8"/>
           <p:cNvSpPr/>
           <p:nvPr/>
         </p:nvSpPr>
@@ -11621,7 +12589,7 @@
       </p:sp>
       <p:sp>
         <p:nvSpPr>
-          <p:cNvPr id="7" name="TextBox 6"/>
+          <p:cNvPr id="10" name="TextBox 9"/>
           <p:cNvSpPr txBox="1"/>
           <p:nvPr/>
         </p:nvSpPr>
@@ -11657,7 +12625,7 @@
       </p:sp>
       <p:sp>
         <p:nvSpPr>
-          <p:cNvPr id="8" name="TextBox 7"/>
+          <p:cNvPr id="11" name="TextBox 10"/>
           <p:cNvSpPr txBox="1"/>
           <p:nvPr/>
         </p:nvSpPr>
@@ -11686,7 +12654,7 @@
               </a:defRPr>
             </a:pPr>
             <a:r>
-              <a:t>20 / 22</a:t>
+              <a:t>21 / 23</a:t>
             </a:r>
           </a:p>
         </p:txBody>
@@ -11699,7 +12667,7 @@
 </p:sld>
 </file>
 
-<file path=ppt/slides/slide21.xml><?xml version="1.0" encoding="utf-8"?>
+<file path=ppt/slides/slide22.xml><?xml version="1.0" encoding="utf-8"?>
 <p:sld xmlns:a="http://schemas.openxmlformats.org/drawingml/2006/main" xmlns:p="http://schemas.openxmlformats.org/presentationml/2006/main" xmlns:r="http://schemas.openxmlformats.org/officeDocument/2006/relationships">
   <p:cSld>
     <p:bg>
@@ -12449,7 +13417,7 @@
               </a:defRPr>
             </a:pPr>
             <a:r>
-              <a:t>• Resources: 8 Dedicated AWS Lambda Functions</a:t>
+              <a:t>• Resources: 21 Graviton ARM64 AWS Lambda Functions</a:t>
             </a:r>
           </a:p>
           <a:p>
@@ -12791,7 +13759,7 @@
               </a:defRPr>
             </a:pPr>
             <a:r>
-              <a:t>21 / 22</a:t>
+              <a:t>22 / 23</a:t>
             </a:r>
           </a:p>
         </p:txBody>
@@ -12804,7 +13772,7 @@
 </p:sld>
 </file>
 
-<file path=ppt/slides/slide22.xml><?xml version="1.0" encoding="utf-8"?>
+<file path=ppt/slides/slide23.xml><?xml version="1.0" encoding="utf-8"?>
 <p:sld xmlns:a="http://schemas.openxmlformats.org/drawingml/2006/main" xmlns:p="http://schemas.openxmlformats.org/presentationml/2006/main" xmlns:r="http://schemas.openxmlformats.org/officeDocument/2006/relationships">
   <p:cSld>
     <p:bg>
@@ -13712,7 +14680,7 @@
                         </a:defRPr>
                       </a:pPr>
                       <a:r>
-                        <a:t>Ingestion Protocol</a:t>
+                        <a:t>Format Transformations</a:t>
                       </a:r>
                     </a:p>
                   </a:txBody>
@@ -13736,7 +14704,7 @@
                         </a:defRPr>
                       </a:pPr>
                       <a:r>
-                        <a:t>Bimodal (Inline ≤4MB, Direct &gt;4MB)</a:t>
+                        <a:t>On-Demand In-Memory PDF</a:t>
                       </a:r>
                     </a:p>
                   </a:txBody>
@@ -13760,7 +14728,7 @@
                         </a:defRPr>
                       </a:pPr>
                       <a:r>
-                        <a:t>API Gateway Streaming Only</a:t>
+                        <a:t>Eager pre-conversion / Permanent storage</a:t>
                       </a:r>
                     </a:p>
                   </a:txBody>
@@ -13784,7 +14752,7 @@
                         </a:defRPr>
                       </a:pPr>
                       <a:r>
-                        <a:t>Bypasses 10 MiB API Gateway ceiling and Lambda memory costs for multi-gigabyte files.</a:t>
+                        <a:t>Pure TypeScript Graviton compute, 14-day auto-purge S3 Lifecycle, WORM lineage preserved.</a:t>
                       </a:r>
                     </a:p>
                   </a:txBody>
@@ -13834,7 +14802,7 @@
                         </a:defRPr>
                       </a:pPr>
                       <a:r>
-                        <a:t>Build-Time GitOps (Ajv In-Memory)</a:t>
+                        <a:t>Build-Time GitOps (Ajv)</a:t>
                       </a:r>
                     </a:p>
                   </a:txBody>
@@ -14007,7 +14975,7 @@
               </a:defRPr>
             </a:pPr>
             <a:r>
-              <a:t>22 / 22</a:t>
+              <a:t>23 / 23</a:t>
             </a:r>
           </a:p>
         </p:txBody>
@@ -14497,7 +15465,7 @@
               </a:defRPr>
             </a:pPr>
             <a:r>
-              <a:t>3 / 22</a:t>
+              <a:t>3 / 23</a:t>
             </a:r>
           </a:p>
         </p:txBody>
@@ -15396,7 +16364,7 @@
               </a:defRPr>
             </a:pPr>
             <a:r>
-              <a:t>4 / 22</a:t>
+              <a:t>4 / 23</a:t>
             </a:r>
           </a:p>
         </p:txBody>
@@ -16359,7 +17327,7 @@
               </a:defRPr>
             </a:pPr>
             <a:r>
-              <a:t>5 / 22</a:t>
+              <a:t>5 / 23</a:t>
             </a:r>
           </a:p>
         </p:txBody>
@@ -17026,7 +17994,7 @@
               </a:defRPr>
             </a:pPr>
             <a:r>
-              <a:t>6 / 22</a:t>
+              <a:t>6 / 23</a:t>
             </a:r>
           </a:p>
         </p:txBody>
@@ -18183,7 +19151,7 @@
               </a:defRPr>
             </a:pPr>
             <a:r>
-              <a:t>7 / 22</a:t>
+              <a:t>7 / 23</a:t>
             </a:r>
           </a:p>
         </p:txBody>
@@ -18866,7 +19834,7 @@
               </a:defRPr>
             </a:pPr>
             <a:r>
-              <a:t>8 / 22</a:t>
+              <a:t>8 / 23</a:t>
             </a:r>
           </a:p>
         </p:txBody>
@@ -19509,7 +20477,7 @@
               </a:defRPr>
             </a:pPr>
             <a:r>
-              <a:t>9 / 22</a:t>
+              <a:t>9 / 23</a:t>
             </a:r>
           </a:p>
         </p:txBody>

</xml_diff>